<commit_message>
Gauntlet R1 build: L6 Lead Your AI Squad — agent definition, role switch made explicit, Critic role object, squad cover art, exemplar squad output + CHECK row, exit keys, what-ifs, deck content gate green, listing per D2
Co-Authored-By: Claude Fable 5.1 <noreply@anthropic.com>
Claude-Session: https://claude.ai/code/session_01VWaJFc84eoA3U4f2VjTKjw
</commit_message>
<xml_diff>
--- a/products/ai-agent-intern/dist/Lead Your AI Squad - Slides.pptx
+++ b/products/ai-agent-intern/dist/Lead Your AI Squad - Slides.pptx
@@ -513,7 +513,7 @@
           <a:p>
             <a:r>
               <a:rPr lang="en-US" dirty="0"/>
-              <a:t>Open on this slide while students settle. Worksheet: Run the Quest, one per student, plus loose-leaf for squad outputs. Plan teams of 3. Fully unplugged by design.</a:t>
+              <a:t>Open on this slide while students settle. Worksheet: Run the Quest, one per student (2 pages), plus one sheet of scrap paper per student for squad outputs. Plan teams of 3 (30 students = 10 teams; remainder rule is in the Activity notes). Fully unplugged by design. Deck follows the lesson plan block for block; minute chips top-right match it.</a:t>
             </a:r>
             <a:endParaRPr lang="en-US" dirty="0"/>
           </a:p>
@@ -601,7 +601,7 @@
           <a:p>
             <a:r>
               <a:rPr lang="en-US" dirty="0"/>
-              <a:t>Leave this up during Leader review. Read it like it ships with your name on it — because it does. Exemplar note to share after round 1 — KEEP: "The schedule works and the title is big and readable, exactly like the card asked." FIX: "The flyer says 'games all night' — Game Night ends at 8 pm. Fix the time, then re-check every fact against the card." If a leader turns harsh: KEEP comes before FIX, and they read the note aloud to their party member.</a:t>
+              <a:t>Leave this up during Leader review. "Read it like it ships with your name on it — because it does." KEY — a filled CHECK row (Sana reviewing DeShawn's planner list): ACCURACY — SHIP IT: "Steps 1–4 use Friday, gym, 6–8 pm straight off the card." TASTE — RUN IT BACK: "Step 3 says 'write the pitch' but never says to 6th graders — it could be for anybody." DONE-NESS — SHIP IT: "All four card parts are covered, and the NOT ON THE CARD flag is a plus." Exemplar note — KEEP: "The time guesses add up to the 23 minutes we have, exactly like the card asked." FIX: "Step 3 needs the words 'for 6th graders' — the card names the audience and the plan dropped it." WHAT IF a leader turns harsh: KEEP before FIX, read aloud. TRANSITION: "Loot checked. Last quest: one for your own life. Bottom of page 2."</a:t>
             </a:r>
             <a:endParaRPr lang="en-US" dirty="0"/>
           </a:p>
@@ -689,7 +689,7 @@
           <a:p>
             <a:r>
               <a:rPr lang="en-US" dirty="0"/>
-              <a:t>Worksheet p.2. Collect. Scoring: Proficient = all four parts labeled, specific enough that a stranger could do it tomorrow. Developing = parts present but vague ("make it good," "soon"). Beginning = a wish, not a quest card ("help me with math"). Sentence starters for support are in the Teacher Guide, p.3.</a:t>
+              <a:t>Worksheet p.2, solo, 6 minutes. Collect. KEY — #1 exemplar (study plan): GOAL: pass Friday's fractions quiz with at least a B. WHAT WE KNOW: 7th grade math; I have the review sheet and 30 minutes a night, Monday to Thursday. RULES OF THE RUN: only fractions with different denominators, no calculators, nothing due before Wednesday. DONE LOOKS LIKE: a four-night plan, 5 practice problems a night with answers on a separate line. Test: could a stranger do it tomorrow from the card alone? Scoring: Proficient = all four parts labeled and specific; Developing = parts present but vague ("make it good," "soon"); Beginning = a wish, not a quest card ("help me with math"). #2: any role with a reason tied to the task (scout for a fact-heavy flyer; planner for a schedule) — the reason is what scores. #3: any check with something real to look for ("accuracy — the quiz date"; "done-ness — did it give all four nights?"). WHAT IF a student writes a wish: "Which part is missing? Add the one that would stop a stranger from guessing." Sentence starters for support: Teacher Guide, p.3.</a:t>
             </a:r>
             <a:endParaRPr lang="en-US" dirty="0"/>
           </a:p>
@@ -777,7 +777,7 @@
           <a:p>
             <a:r>
               <a:rPr lang="en-US" dirty="0"/>
-              <a:t>Close on this — it's the leader rule from the bottom of the worksheet. This is Lesson 6 of 6, the capstone: the quest card is Lesson 1's prompting, the accuracy check is Lesson 3's fact desk, the taste check is Lesson 4's feedback eye. They already had the skills; today they found out the skills make them a leader. With devices: run a team's card through a real AI tool and review its output with the same rubric.</a:t>
+              <a:t>Close on this — it's the leader rule from the bottom of the worksheet. This is Lesson 6 of 6; the unit ends here, and every lesson stands alone. (If your class did the earlier lessons: the quest card is the genie-proof prompt, the accuracy check is the fact desk, the taste check is the feedback eye — they had the skills; today they found out the skills make them a leader.) With devices: the five-line block in the lesson plan runs one team's card on your projected account and the class checks its output with the same rubric. Hedge if asked about jobs: AI agents take over tasks, not whole jobs — nobody can promise the final count.</a:t>
             </a:r>
             <a:endParaRPr lang="en-US" dirty="0"/>
           </a:p>
@@ -865,7 +865,7 @@
           <a:p>
             <a:r>
               <a:rPr lang="en-US" dirty="0"/>
-              <a:t>Tell the class about last night's run and read the three orders with a straight face. Lesson 1 alumni will call it: this party member IS the literal genie — it just joined your squad. New classes need no backstory. Then advance to the question.</a:t>
+              <a:t>Tell the class about last night's run and read the three orders with a straight face. (If your class did the genie lesson, someone will call it: this party member IS the literal genie — it just joined your squad. New classes need no backstory.) WHAT IF nobody laughs: ask for a fourth order from the room and ruin it the same way — "Heal me" → healed you. Once. Then advance to the question.</a:t>
             </a:r>
             <a:endParaRPr lang="en-US" dirty="0"/>
           </a:p>
@@ -953,7 +953,7 @@
           <a:p>
             <a:r>
               <a:rPr lang="en-US" dirty="0"/>
-              <a:t>Bridge: "An AI agent is this party member: fast, tireless, never salty — and it does exactly what the quest says. You'll never out-grind it. You CAN out-lead it. Today you learn the leader's loop: quest card, roles, check the loot — then ship it or run it back."</a:t>
+              <a:t>Take two or three answers. Bridge: "An AI agent doesn't just answer — it does a whole job in steps: makes a plan, looks things up, uses tools, and hands you a finished thing. Where your quest card is vague, it fills the gap with its best guess and keeps going. That's why the leader checks. You'll never out-work it. You CAN out-lead it." TRANSITION: "Today you learn the leader's loop: quest card, roles, check the loot — then ship it or run it back. Four parts. Board."</a:t>
             </a:r>
             <a:endParaRPr lang="en-US" dirty="0"/>
           </a:p>
@@ -1041,7 +1041,7 @@
           <a:p>
             <a:r>
               <a:rPr lang="en-US" dirty="0"/>
-              <a:t>Write the loop on the board as you go: QUEST CARD → ROLES → CHECK THE LOOT → SHIP IT or RUN IT BACK. Each part gets its own slide next; this one is the map.</a:t>
+              <a:t>Write the loop on the board as you go: QUEST CARD → ROLES → CHECK THE LOOT → SHIP IT or RUN IT BACK. Gloss the two verdicts out loud the first time: SHIP IT = good to go; RUN IT BACK = do it again. Each part gets its own slide next; this one is the map.</a:t>
             </a:r>
             <a:endParaRPr lang="en-US" dirty="0"/>
           </a:p>
@@ -1129,7 +1129,7 @@
           <a:p>
             <a:r>
               <a:rPr lang="en-US" dirty="0"/>
-              <a:t>Prompt-writers from Lesson 1: this is P.R.O. grown up. How to score any quest card: hand it to the most literal reader in the room. If they can twist it, or have to guess, a part is missing or vague.</a:t>
+              <a:t>(If your class did the genie lesson: this is P.R.O. grown up — Purpose became Goal + What We Know, Requirements became Rules, Output became Done Looks Like.) How to score any quest card: hand it to the most literal reader in the room. If they can twist it, or have to guess, a part is missing or vague. TRANSITION: "Let's build one together."</a:t>
             </a:r>
             <a:endParaRPr lang="en-US" dirty="0"/>
           </a:p>
@@ -1217,7 +1217,7 @@
           <a:p>
             <a:r>
               <a:rPr lang="en-US" dirty="0"/>
-              <a:t>Build the right-hand card on the board part by part, labeling each: GOAL, WHAT WE KNOW, RULES OF THE RUN, DONE LOOKS LIKE. Ask: what could a literal party member still twist? Anything they name is a missing rule.</a:t>
+              <a:t>Build the right-hand card on the board part by part, labeling each: GOAL, WHAT WE KNOW, RULES OF THE RUN, DONE LOOKS LIKE (the full card is in the lesson plan). Ask: what could a literal party member still twist? Anything they name is a missing rule. WHAT IF a student says the card is "too long": count it — four lines. "Four lines now, or a flyer that says 'games all night' later."</a:t>
             </a:r>
             <a:endParaRPr lang="en-US" dirty="0"/>
           </a:p>
@@ -1305,7 +1305,7 @@
           <a:p>
             <a:r>
               <a:rPr lang="en-US" dirty="0"/>
-              <a:t>Say it plainly: "Party leaders don't do the quest twice. If you have to redo a party member's work, your quest card failed. Fix the card, not just the work." Then move to the roles.</a:t>
+              <a:t>Say it plainly: "Party leaders don't do the quest twice. If you have to redo a party member's work, your quest card failed. Fix the card, not just the work." TRANSITION: "Three roles. Same card, one slice each. Here they are."</a:t>
             </a:r>
             <a:endParaRPr lang="en-US" dirty="0"/>
           </a:p>
@@ -1393,7 +1393,7 @@
           <a:p>
             <a:r>
               <a:rPr lang="en-US" dirty="0"/>
-              <a:t>You are the leader; your teammates are your agents. Coaching: the planner's NOT ON THE CARD flags are gold — they're the next card's fixes. A scout's fact with no source is a guess wearing a costume. Vague praise from a critic doesn't count.</a:t>
+              <a:t>KEY — what good output looks like (Game Night card): PLANNER: 1. Pick the games and TV set-up (5 min) 2. Write the flyer title and the when/where line (5 min) 3. Add a 40-word pitch to 6th graders (10 min) 4. Count words, check the rules (3 min) 5. NOT ON THE CARD: who photocopies it, and how many? SCOUT: Friday ✓ (on the card) · gym ✓ (on the card) · 6–8 pm ✓ (on the card) · both TVs actually work? ? (ask whoever runs the gym) · how many 6th graders there are ? (the front office). CRITIC: (1) Put the TVs and the games in the title — 6th graders come for the games, not the date. (2) Cut the 40 words to 25; nobody reads a wall of text on a wall. (3) Add one line for parents: pick-up is at 8. Coaching: the planner's NOT ON THE CARD flags are gold — they're the next card's fixes. A scout's fact with no "how we know" is a guess wearing a costume. Vague praise from a critic doesn't count. TRANSITION: "Page 1. Pick your quest. One card per team — everyone copies it. Six minutes."</a:t>
             </a:r>
             <a:endParaRPr lang="en-US" dirty="0"/>
           </a:p>
@@ -1481,7 +1481,7 @@
           <a:p>
             <a:r>
               <a:rPr lang="en-US" dirty="0"/>
-              <a:t>In Sana's squad: DeShawn plans, Lucia scouts, Sana critiques; then Sana reviews DeShawn, DeShawn reviews Lucia, Lucia reviews Sana. Enforce the silence — when a party member asks a question mid-round, answer: "It's not on the card." The frustration is the point. Don't rescue a weak card; the review makes the failure visible and fixable. Team of 4: two critics. Team of 2: drop the critic; the leader does the taste check.</a:t>
+              <a:t>WRITE THE CARD — WHAT IF a team stalls on GOAL: "What would make you say we won?" TRANSITION at 6 min: "Cards done. Now switch: for 8 minutes YOU play an AI agent. Take a role card. Silence starts now." SQUAD WORKS — in Sana's squad: DeShawn plans, Lucia scouts, Sana critiques. At 4 min call: "Planners, slide your list to your Critic — keep adding your time guesses." Enforce the silence — when a party member asks a question mid-round, answer: "It's not on the card." The frustration is the point. Don't rescue a weak card; the review makes the failure visible and fixable. WHAT IF the class doesn't divide by 3: team of 4 = two critics (both read the plan); team of 2 = drop the critic, the leader does the taste check. 30 students = 10 teams. TRANSITION at 8 min: "Time. Pass your paper one seat left. You're the leader again — page 2." LEADER REVIEW — Sana reviews DeShawn, DeShawn reviews Lucia, Lucia reviews Sana. WHAT IF a leader turns harsh: KEEP comes before FIX, and they read the note aloud to their party member. Next slide stays up during the review.</a:t>
             </a:r>
             <a:endParaRPr lang="en-US" dirty="0"/>
           </a:p>
@@ -2059,7 +2059,7 @@
               <a:buNone/>
             </a:pPr>
             <a:r>
-              <a:rPr lang="en-US" sz="1400" dirty="0">
+              <a:rPr lang="en-US" sz="1200" dirty="0">
                 <a:solidFill>
                   <a:srgbClr val="E8E8F5"/>
                 </a:solidFill>
@@ -2067,9 +2067,9 @@
                 <a:ea typeface="Arial" pitchFamily="34" charset="-122"/>
                 <a:cs typeface="Arial" pitchFamily="34" charset="-120"/>
               </a:rPr>
-              <a:t>An AI agent is a party member: capable, tireless, EXTREMELY literal. Party leaders don't redo the squad's work — they write the quest card, assign the roles, and check the loot.</a:t>
-            </a:r>
-            <a:endParaRPr lang="en-US" sz="1400" dirty="0"/>
+              <a:t>An AI agent does a multi-step job on its own — and where your card is vague, it guesses forward. Party leaders don't redo the squad's work: they write the quest card, hand out the roles, and check the loot.</a:t>
+            </a:r>
+            <a:endParaRPr lang="en-US" sz="1200" dirty="0"/>
           </a:p>
         </p:txBody>
       </p:sp>
@@ -2214,7 +2214,7 @@
         <p:spPr>
           <a:xfrm>
             <a:off x="3204972" y="3977640"/>
-            <a:ext cx="1485900" cy="310896"/>
+            <a:ext cx="2418588" cy="310896"/>
           </a:xfrm>
           <a:prstGeom prst="roundRect">
             <a:avLst>
@@ -2241,7 +2241,7 @@
         <p:spPr>
           <a:xfrm>
             <a:off x="3204972" y="3977640"/>
-            <a:ext cx="1485900" cy="310896"/>
+            <a:ext cx="2418588" cy="310896"/>
           </a:xfrm>
           <a:prstGeom prst="rect">
             <a:avLst/>
@@ -2265,7 +2265,7 @@
                 <a:ea typeface="Arial" pitchFamily="34" charset="-122"/>
                 <a:cs typeface="Arial" pitchFamily="34" charset="-120"/>
               </a:rPr>
-              <a:t>Works unplugged</a:t>
+              <a:t>No prep · No devices needed</a:t>
             </a:r>
             <a:endParaRPr lang="en-US" sz="1000" dirty="0"/>
           </a:p>
@@ -2457,7 +2457,7 @@
                 <a:ea typeface="Arial" pitchFamily="34" charset="-122"/>
                 <a:cs typeface="Arial" pitchFamily="34" charset="-120"/>
               </a:rPr>
-              <a:t>ACCURACY — Is every stated fact verified?</a:t>
+              <a:t>ACCURACY — Does every fact match the card? Is every ✓ backed by a "how we know"?</a:t>
             </a:r>
             <a:endParaRPr lang="en-US" sz="1800" dirty="0"/>
           </a:p>
@@ -2478,7 +2478,7 @@
                 <a:ea typeface="Arial" pitchFamily="34" charset="-122"/>
                 <a:cs typeface="Arial" pitchFamily="34" charset="-120"/>
               </a:rPr>
-              <a:t>TASTE — Does it fit the audience and vibe on the card, or is it generic?</a:t>
+              <a:t>TASTE — Does it fit the audience and tone on the card, or could it be for anybody?</a:t>
             </a:r>
             <a:endParaRPr lang="en-US" sz="1800" dirty="0"/>
           </a:p>
@@ -2520,7 +2520,7 @@
                 <a:ea typeface="Arial" pitchFamily="34" charset="-122"/>
                 <a:cs typeface="Arial" pitchFamily="34" charset="-120"/>
               </a:rPr>
-              <a:t>Each check: SHIP IT or RUN IT BACK. Quote the evidence.</a:t>
+              <a:t>Each check: SHIP IT (good to go) or RUN IT BACK (do it again). Quote the evidence.</a:t>
             </a:r>
             <a:endParaRPr lang="en-US" sz="1800" dirty="0"/>
           </a:p>
@@ -2799,7 +2799,7 @@
                 <a:ea typeface="Arial" pitchFamily="34" charset="-122"/>
                 <a:cs typeface="Arial" pitchFamily="34" charset="-120"/>
               </a:rPr>
-              <a:t>Pick one real task in YOUR life to hand an AI agent this week — a study plan, a chore schedule, a team flyer.</a:t>
+              <a:t>1.  Pick one real task in YOUR life to hand an AI agent this week — a study plan, a chore list, a team flyer.</a:t>
             </a:r>
             <a:endParaRPr lang="en-US" sz="1800" dirty="0"/>
           </a:p>
@@ -2820,7 +2820,7 @@
                 <a:ea typeface="Arial" pitchFamily="34" charset="-122"/>
                 <a:cs typeface="Arial" pitchFamily="34" charset="-120"/>
               </a:rPr>
-              <a:t>Write the full quest card, all four parts labeled: GOAL · WHAT WE KNOW · RULES OF THE RUN · DONE LOOKS LIKE.</a:t>
+              <a:t>     Write the full quest card: GOAL · WHAT WE KNOW · RULES OF THE RUN · DONE LOOKS LIKE.</a:t>
             </a:r>
             <a:endParaRPr lang="en-US" sz="1800" dirty="0"/>
           </a:p>
@@ -2841,7 +2841,28 @@
                 <a:ea typeface="Arial" pitchFamily="34" charset="-122"/>
                 <a:cs typeface="Arial" pitchFamily="34" charset="-120"/>
               </a:rPr>
-              <a:t>Test: could a stranger do the task tomorrow from your card alone?</a:t>
+              <a:t>2.  Which role would you hand it to first — planner, scout or critic? Tick one and say why.</a:t>
+            </a:r>
+            <a:endParaRPr lang="en-US" sz="1800" dirty="0"/>
+          </a:p>
+          <a:p>
+            <a:pPr marL="342900" indent="-342900">
+              <a:spcAft>
+                <a:spcPts val="800"/>
+              </a:spcAft>
+              <a:buSzPct val="100000"/>
+              <a:buChar char="■"/>
+            </a:pPr>
+            <a:r>
+              <a:rPr lang="en-US" sz="1800" dirty="0">
+                <a:solidFill>
+                  <a:srgbClr val="E8E8F5"/>
+                </a:solidFill>
+                <a:latin typeface="Arial" pitchFamily="34" charset="0"/>
+                <a:ea typeface="Arial" pitchFamily="34" charset="-122"/>
+                <a:cs typeface="Arial" pitchFamily="34" charset="-120"/>
+              </a:rPr>
+              <a:t>3.  Which check would it most likely fail — accuracy, taste or done-ness? Tick one; say what you'd look for.</a:t>
             </a:r>
             <a:endParaRPr lang="en-US" sz="1800" dirty="0"/>
           </a:p>
@@ -3772,7 +3793,7 @@
                 <a:ea typeface="Arial" pitchFamily="34" charset="-122"/>
                 <a:cs typeface="Arial" pitchFamily="34" charset="-120"/>
               </a:rPr>
-              <a:t>An AI agent is this party member: fast, tireless, never salty — and it does exactly what the quest says.</a:t>
+              <a:t>An AI agent does a multi-step job on its own — and where your card is vague, it guesses forward.</a:t>
             </a:r>
             <a:endParaRPr lang="en-US" sz="1600" dirty="0"/>
           </a:p>
@@ -4156,7 +4177,7 @@
                 <a:ea typeface="Arial" pitchFamily="34" charset="-122"/>
                 <a:cs typeface="Arial" pitchFamily="34" charset="-120"/>
               </a:rPr>
-              <a:t>Write the job down, all four parts. If the card is vague, the squad guesses — and guesses wrong.</a:t>
+              <a:t>Write the job down, all four parts. A vague card makes the squad guess — and guess wrong.</a:t>
             </a:r>
             <a:endParaRPr lang="en-US" sz="1400" dirty="0"/>
           </a:p>
@@ -4317,7 +4338,7 @@
               <a:buNone/>
             </a:pPr>
             <a:r>
-              <a:rPr lang="en-US" sz="1300" dirty="0">
+              <a:rPr lang="en-US" sz="1400" dirty="0">
                 <a:solidFill>
                   <a:srgbClr val="E8E8F5"/>
                 </a:solidFill>
@@ -4325,9 +4346,9 @@
                 <a:ea typeface="Arial" pitchFamily="34" charset="-122"/>
                 <a:cs typeface="Arial" pitchFamily="34" charset="-120"/>
               </a:rPr>
-              <a:t>Leaders don't send one member to solo the raid. Split it: a planner, a scout, a critic — same card, one slice each.</a:t>
-            </a:r>
-            <a:endParaRPr lang="en-US" sz="1300" dirty="0"/>
+              <a:t>Nobody solos the raid. Split it: a planner, a scout, a critic — same card, one slice each.</a:t>
+            </a:r>
+            <a:endParaRPr lang="en-US" sz="1400" dirty="0"/>
           </a:p>
         </p:txBody>
       </p:sp>
@@ -4494,7 +4515,7 @@
                 <a:ea typeface="Arial" pitchFamily="34" charset="-122"/>
                 <a:cs typeface="Arial" pitchFamily="34" charset="-120"/>
               </a:rPr>
-              <a:t>The leader reviews every output: accuracy, taste, done-ness. Nothing ships unchecked.</a:t>
+              <a:t>The leader checks every output: accuracy, taste, done-ness. Nothing ships unchecked.</a:t>
             </a:r>
             <a:endParaRPr lang="en-US" sz="1400" dirty="0"/>
           </a:p>
@@ -4616,7 +4637,7 @@
               <a:buNone/>
             </a:pPr>
             <a:r>
-              <a:rPr lang="en-US" sz="1400" b="1" dirty="0">
+              <a:rPr lang="en-US" sz="1600" b="1" dirty="0">
                 <a:solidFill>
                   <a:srgbClr val="FFB020"/>
                 </a:solidFill>
@@ -4624,9 +4645,9 @@
                 <a:ea typeface="Arial" pitchFamily="34" charset="-122"/>
                 <a:cs typeface="Arial" pitchFamily="34" charset="-120"/>
               </a:rPr>
-              <a:t>Ship It or Run It Back</a:t>
-            </a:r>
-            <a:endParaRPr lang="en-US" sz="1400" dirty="0"/>
+              <a:t>The Verdict</a:t>
+            </a:r>
+            <a:endParaRPr lang="en-US" sz="1600" dirty="0"/>
           </a:p>
         </p:txBody>
       </p:sp>
@@ -4655,7 +4676,7 @@
               <a:buNone/>
             </a:pPr>
             <a:r>
-              <a:rPr lang="en-US" sz="1300" dirty="0">
+              <a:rPr lang="en-US" sz="1400" dirty="0">
                 <a:solidFill>
                   <a:srgbClr val="E8E8F5"/>
                 </a:solidFill>
@@ -4663,9 +4684,9 @@
                 <a:ea typeface="Arial" pitchFamily="34" charset="-122"/>
                 <a:cs typeface="Arial" pitchFamily="34" charset="-120"/>
               </a:rPr>
-              <a:t>Good work ships. Weak work gets a run-it-back note — keep + fix, specific enough that nobody guesses.</a:t>
-            </a:r>
-            <a:endParaRPr lang="en-US" sz="1300" dirty="0"/>
+              <a:t>SHIP IT (good to go) or RUN IT BACK (do it again) — with a keep + fix note, specific.</a:t>
+            </a:r>
+            <a:endParaRPr lang="en-US" sz="1400" dirty="0"/>
           </a:p>
         </p:txBody>
       </p:sp>
@@ -5637,7 +5658,7 @@
                 <a:ea typeface="Arial" pitchFamily="34" charset="-122"/>
                 <a:cs typeface="Arial" pitchFamily="34" charset="-120"/>
               </a:rPr>
-              <a:t>Model it live</a:t>
+              <a:t>Watch one get fixed</a:t>
             </a:r>
             <a:endParaRPr lang="en-US" sz="2600" dirty="0"/>
           </a:p>
@@ -5839,7 +5860,7 @@
               <a:buNone/>
             </a:pPr>
             <a:r>
-              <a:rPr lang="en-US" sz="1600" dirty="0">
+              <a:rPr lang="en-US" sz="1700" dirty="0">
                 <a:solidFill>
                   <a:srgbClr val="FFFFFF"/>
                 </a:solidFill>
@@ -5847,9 +5868,9 @@
                 <a:ea typeface="Arial" pitchFamily="34" charset="-122"/>
                 <a:cs typeface="Arial" pitchFamily="34" charset="-120"/>
               </a:rPr>
-              <a:t>"GOAL: get 6th graders to actually show up to Game Night. WHAT WE KNOW: Friday, gym, 6–8 pm; we have board games and two TVs. RULES OF THE RUN: school-appropriate, big readable title, 40 words max. DONE LOOKS LIKE: one flyer draft, ready to photocopy."</a:t>
-            </a:r>
-            <a:endParaRPr lang="en-US" sz="1600" dirty="0"/>
+              <a:t>GOAL: get 6th graders to show up. WHAT WE KNOW: Friday, gym, 6–8 pm; board games, two TVs. RULES: school-appropriate, big title, 40 words max. DONE: one flyer draft.</a:t>
+            </a:r>
+            <a:endParaRPr lang="en-US" sz="1700" dirty="0"/>
           </a:p>
         </p:txBody>
       </p:sp>
@@ -6392,7 +6413,7 @@
                 <a:ea typeface="Arial" pitchFamily="34" charset="-122"/>
                 <a:cs typeface="Arial" pitchFamily="34" charset="-120"/>
               </a:rPr>
-              <a:t>Turn the card into a numbered step list with a time guess per step. If the card is silent, write "NOT ON THE CARD" — don't guess.</a:t>
+              <a:t>Turn the card into a numbered step list with a time guess per step. Card silent on something? Write "NOT ON THE CARD" — don't guess.</a:t>
             </a:r>
             <a:endParaRPr lang="en-US" sz="1400" dirty="0"/>
           </a:p>
@@ -6561,7 +6582,7 @@
                 <a:ea typeface="Arial" pitchFamily="34" charset="-122"/>
                 <a:cs typeface="Arial" pitchFamily="34" charset="-120"/>
               </a:rPr>
-              <a:t>List every fact the quest needs. Mark each ✓ verified (say where) or ? needs checking. No guesses dressed as facts.</a:t>
+              <a:t>List every fact the quest needs. Mark each ✓ (we know it for sure — say how) or ? (needs checking — say where).</a:t>
             </a:r>
             <a:endParaRPr lang="en-US" sz="1400" dirty="0"/>
           </a:p>
@@ -6730,7 +6751,7 @@
                 <a:ea typeface="Arial" pitchFamily="34" charset="-122"/>
                 <a:cs typeface="Arial" pitchFamily="34" charset="-120"/>
               </a:rPr>
-              <a:t>Write 3 specific upgrades tied to the audience on the card. "Make it better" is banned — name the exact change and why.</a:t>
+              <a:t>Read the card as the audience. At the 4-minute call, read the Planner's list and write 3 upgrades to that plan. "Make it better" is banned.</a:t>
             </a:r>
             <a:endParaRPr lang="en-US" sz="1400" dirty="0"/>
           </a:p>
@@ -7087,7 +7108,7 @@
                 <a:ea typeface="Arial" pitchFamily="34" charset="-122"/>
                 <a:cs typeface="Arial" pitchFamily="34" charset="-120"/>
               </a:rPr>
-              <a:t>Teams of 3. Pick a quest — Game Night page or zine issue #1 — and write ONE card with all four parts. Everyone copies it.</a:t>
+              <a:t>Teams of 3. Pick a quest — Game Night page or class magazine issue #1 — and write ONE card, all four parts. Everyone copies it.</a:t>
             </a:r>
             <a:endParaRPr lang="en-US" sz="1300" dirty="0"/>
           </a:p>
@@ -7229,7 +7250,7 @@
                 <a:ea typeface="Arial" pitchFamily="34" charset="-122"/>
                 <a:cs typeface="Arial" pitchFamily="34" charset="-120"/>
               </a:rPr>
-              <a:t>Take a role card: planner, scout, critic. Work SILENTLY, from the card alone, on your own paper. No questions — agents can't read minds.</a:t>
+              <a:t>Now switch: YOU play an AI agent. Take a role card and work SILENTLY, from the card alone, on your own paper. No questions — agents can't read minds.</a:t>
             </a:r>
             <a:endParaRPr lang="en-US" sz="1300" dirty="0"/>
           </a:p>
@@ -7371,7 +7392,7 @@
                 <a:ea typeface="Arial" pitchFamily="34" charset="-122"/>
                 <a:cs typeface="Arial" pitchFamily="34" charset="-120"/>
               </a:rPr>
-              <a:t>Rotate: review ONE other player's output. Run the CHECK rubric, rule SHIP IT or RUN IT BACK, and write one run-it-back note.</a:t>
+              <a:t>Pass your paper one seat left — you're the leader again. Run the CHECK rubric on one party member's work: SHIP IT or RUN IT BACK, then the note.</a:t>
             </a:r>
             <a:endParaRPr lang="en-US" sz="1300" dirty="0"/>
           </a:p>

</xml_diff>

<commit_message>
Gauntlet R2 fixes: L6 papers never move mid-round, Critic 0–4 task, consistent exemplar key, one-of verdicts, 72px evidence boxes, check not tick
Co-Authored-By: Claude Fable 5.1 <noreply@anthropic.com>
Claude-Session: https://claude.ai/code/session_01VWaJFc84eoA3U4f2VjTKjw
</commit_message>
<xml_diff>
--- a/products/ai-agent-intern/dist/Lead Your AI Squad - Slides.pptx
+++ b/products/ai-agent-intern/dist/Lead Your AI Squad - Slides.pptx
@@ -601,7 +601,7 @@
           <a:p>
             <a:r>
               <a:rPr lang="en-US" dirty="0"/>
-              <a:t>Leave this up during Leader review. "Read it like it ships with your name on it — because it does." KEY — a filled CHECK row (Sana reviewing DeShawn's planner list): ACCURACY — SHIP IT: "Steps 1–4 use Friday, gym, 6–8 pm straight off the card." TASTE — RUN IT BACK: "Step 3 says 'write the pitch' but never says to 6th graders — it could be for anybody." DONE-NESS — SHIP IT: "All four card parts are covered, and the NOT ON THE CARD flag is a plus." Exemplar note — KEEP: "The time guesses add up to the 23 minutes we have, exactly like the card asked." FIX: "Step 3 needs the words 'for 6th graders' — the card names the audience and the plan dropped it." WHAT IF a leader turns harsh: KEEP before FIX, read aloud. TRANSITION: "Loot checked. Last quest: one for your own life. Bottom of page 2."</a:t>
+              <a:t>Leave this up during Leader review. "Read it like your name is on it — because it is." KEY — a filled CHECK row (Lucia reviewing DeShawn's planner list): ACCURACY — SHIP IT: "Steps 1–4 use Friday, gym, 6–8 pm straight off the card." TASTE — RUN IT BACK: "Step 3 says 'write the pitch' but never says to 6th graders — it could be for anybody." DONE-NESS — SHIP IT: "All four card parts are covered, and the NOT ON THE CARD flag is a plus." Exemplar note — KEEP: "Every step has a time guess and all four card parts are covered." FIX: "Step 3 needs the words 'for 6th graders' — the card names the audience and the plan dropped it." WHAT IF a leader turns harsh: KEEP before FIX, read aloud. TRANSITION: "Loot checked. Last quest: one for your own life. Bottom of page 2."</a:t>
             </a:r>
             <a:endParaRPr lang="en-US" dirty="0"/>
           </a:p>
@@ -689,7 +689,7 @@
           <a:p>
             <a:r>
               <a:rPr lang="en-US" dirty="0"/>
-              <a:t>Worksheet p.2, solo, 6 minutes. Collect. KEY — #1 exemplar (study plan): GOAL: pass Friday's fractions quiz with at least a B. WHAT WE KNOW: 7th grade math; I have the review sheet and 30 minutes a night, Monday to Thursday. RULES OF THE RUN: only fractions with different denominators, no calculators, nothing due before Wednesday. DONE LOOKS LIKE: a four-night plan, 5 practice problems a night with answers on a separate line. Test: could a stranger do it tomorrow from the card alone? Scoring: Proficient = all four parts labeled and specific; Developing = parts present but vague ("make it good," "soon"); Beginning = a wish, not a quest card ("help me with math"). #2: any role with a reason tied to the task (scout for a fact-heavy flyer; planner for a schedule) — the reason is what scores. #3: any check with something real to look for ("accuracy — the quiz date"; "done-ness — did it give all four nights?"). WHAT IF a student writes a wish: "Which part is missing? Add the one that would stop a stranger from guessing." Sentence starters for support: Teacher Guide, p.3.</a:t>
+              <a:t>Worksheet p.2, solo, 6 minutes. Collect. KEY — #1 exemplar (study plan): GOAL: pass Friday's fractions quiz with at least a B. WHAT WE KNOW: 7th grade math; I have the review sheet and 30 minutes a night, Monday to Thursday. RULES OF THE RUN: only fractions with different denominators, no calculators, nothing due before Wednesday. DONE LOOKS LIKE: a four-night plan, 5 practice problems a night with answers on a separate line. Test: could a stranger do it tomorrow from the card alone? Scoring: Proficient = all four parts labeled and specific; Developing = parts present but vague ("make it good," "soon"); Beginning = a wish, not a quest card ("help me with math"). #2: any role with a reason tied to the task (scout for a fact-heavy flyer; planner for a schedule) — the reason is what scores. #3: any check with something real to look for ("accuracy — the quiz date"; "done-ness — did it give all four nights?"). WHAT IF a student writes a wish: "Which part is missing? Add the one that would stop a stranger from guessing." Sentence starters for support: Teacher Guide, p.2.</a:t>
             </a:r>
             <a:endParaRPr lang="en-US" dirty="0"/>
           </a:p>
@@ -1217,7 +1217,7 @@
           <a:p>
             <a:r>
               <a:rPr lang="en-US" dirty="0"/>
-              <a:t>Build the right-hand card on the board part by part, labeling each: GOAL, WHAT WE KNOW, RULES OF THE RUN, DONE LOOKS LIKE (the full card is in the lesson plan). Ask: what could a literal party member still twist? Anything they name is a missing rule. WHAT IF a student says the card is "too long": count it — four lines. "Four lines now, or a flyer that says 'games all night' later."</a:t>
+              <a:t>Start with the cursed order — "Plan the game night." — then build the card on the board part by part, labeling each: GOAL, WHAT WE KNOW, RULES OF THE RUN, DONE LOOKS LIKE (same wording as the lesson plan). Ask: what could a literal party member still twist? Anything they name is a missing rule. WHAT IF a student says the card is "too long": count it — four lines. "Four lines now, or a flyer that says 'games all night' later."</a:t>
             </a:r>
             <a:endParaRPr lang="en-US" dirty="0"/>
           </a:p>
@@ -1393,7 +1393,7 @@
           <a:p>
             <a:r>
               <a:rPr lang="en-US" dirty="0"/>
-              <a:t>KEY — what good output looks like (Game Night card): PLANNER: 1. Pick the games and TV set-up (5 min) 2. Write the flyer title and the when/where line (5 min) 3. Add a 40-word pitch to 6th graders (10 min) 4. Count words, check the rules (3 min) 5. NOT ON THE CARD: who photocopies it, and how many? SCOUT: Friday ✓ (on the card) · gym ✓ (on the card) · 6–8 pm ✓ (on the card) · both TVs actually work? ? (ask whoever runs the gym) · how many 6th graders there are ? (the front office). CRITIC: (1) Put the TVs and the games in the title — 6th graders come for the games, not the date. (2) Cut the 40 words to 25; nobody reads a wall of text on a wall. (3) Add one line for parents: pick-up is at 8. Coaching: the planner's NOT ON THE CARD flags are gold — they're the next card's fixes. A scout's fact with no "how we know" is a guess wearing a costume. Vague praise from a critic doesn't count. TRANSITION: "Page 1. Pick your quest. One card per team — everyone copies it. Six minutes."</a:t>
+              <a:t>KEY — what good output looks like (Game Night card): PLANNER: 1. Pick the games and TV set-up (5 min) 2. Write the flyer title and the when/where line (5 min) 3. ★ Add a 40-word pitch (10 min) 4. Count words, check the rules (3 min) 5. NOT ON THE CARD: who photocopies it, and how many? (Minutes 4–8 add the time guesses and the star.) SCOUT: Friday ✓ (on the card) · gym ✓ (on the card) · 6–8 pm ✓ (on the card) · both TVs actually work? ? (ask whoever runs the gym) · how many 6th graders there are ? (the front office). CRITIC: minutes 0–4, what the audience cares about: which games, and whether friends are going. Upgrades: (1) Put the TVs and the games in the title — 6th graders come for the games, not the date. (2) Cut the 40 words to 25; nobody reads a wall of text on a wall. (3) Add one line for parents: pick-up is at 8. Paper logic: papers never move mid-round; at the 4-minute call the Critic reads the Planner's list over their shoulder. Seat Planner → Scout → Critic so the swap (own paper, one seat left) lands each paper on a fresh reader. Coaching: the planner's NOT ON THE CARD flags are gold — they're the next card's fixes. A scout's fact with no "how we know" is a guess wearing a costume. Vague praise from a critic doesn't count. TRANSITION: "Page 1. Pick your quest. One card per team — everyone copies it. Six minutes."</a:t>
             </a:r>
             <a:endParaRPr lang="en-US" dirty="0"/>
           </a:p>
@@ -1481,7 +1481,7 @@
           <a:p>
             <a:r>
               <a:rPr lang="en-US" dirty="0"/>
-              <a:t>WRITE THE CARD — WHAT IF a team stalls on GOAL: "What would make you say we won?" TRANSITION at 6 min: "Cards done. Now switch: for 8 minutes YOU play an AI agent. Take a role card. Silence starts now." SQUAD WORKS — in Sana's squad: DeShawn plans, Lucia scouts, Sana critiques. At 4 min call: "Planners, slide your list to your Critic — keep adding your time guesses." Enforce the silence — when a party member asks a question mid-round, answer: "It's not on the card." The frustration is the point. Don't rescue a weak card; the review makes the failure visible and fixable. WHAT IF the class doesn't divide by 3: team of 4 = two critics (both read the plan); team of 2 = drop the critic, the leader does the taste check. 30 students = 10 teams. TRANSITION at 8 min: "Time. Pass your paper one seat left. You're the leader again — page 2." LEADER REVIEW — Sana reviews DeShawn, DeShawn reviews Lucia, Lucia reviews Sana. WHAT IF a leader turns harsh: KEEP comes before FIX, and they read the note aloud to their party member. Next slide stays up during the review.</a:t>
+              <a:t>WRITE THE CARD — WHAT IF a team stalls on GOAL: "What would make you say we won?" TRANSITION at 6 min: "Cards done. Sit Planner → Scout → Critic. Now switch: for 8 minutes YOU play an AI agent. Take a role card. Silence starts now." SQUAD WORKS — in Sana's squad: DeShawn plans, Lucia scouts, Sana critiques. Papers never move mid-round. At the 4-minute call: "Critics, read your Planner's list over their shoulder — 3 upgrades. Planners, add a time guess to every step and star the one most likely to go wrong." Enforce the silence — when a party member asks a question mid-round, answer: "It's not on the card." The frustration is the point. Don't rescue a weak card; the review makes the failure visible and fixable. WHAT IF the class doesn't divide by 3: team of 4 = two critics (both read the plan); team of 2 = drop the critic, the leader does the taste check. 30 students = 10 teams. TRANSITION at 8 min: "Time. Every party member passes their OWN paper one seat left. You're the leader again — page 2." LEADER REVIEW — with the Planner → Scout → Critic seating, Lucia reviews DeShawn's plan, Sana reviews Lucia's facts, DeShawn reviews Sana's upgrades: the Critic never re-reviews the Planner's list. WHAT IF a leader turns harsh: KEEP comes before FIX, and they read the note aloud to their party member. Next slide stays up during the review.</a:t>
             </a:r>
             <a:endParaRPr lang="en-US" dirty="0"/>
           </a:p>
@@ -2133,7 +2133,7 @@
                 <a:ea typeface="Arial" pitchFamily="34" charset="-122"/>
                 <a:cs typeface="Arial" pitchFamily="34" charset="-120"/>
               </a:rPr>
-              <a:t>Grades 6-8</a:t>
+              <a:t>Grades 6–8</a:t>
             </a:r>
             <a:endParaRPr lang="en-US" sz="1000" dirty="0"/>
           </a:p>
@@ -2841,7 +2841,7 @@
                 <a:ea typeface="Arial" pitchFamily="34" charset="-122"/>
                 <a:cs typeface="Arial" pitchFamily="34" charset="-120"/>
               </a:rPr>
-              <a:t>2.  Which role would you hand it to first — planner, scout or critic? Tick one and say why.</a:t>
+              <a:t>2.  Which role would you hand it to first — planner, scout or critic? Check one and say why.</a:t>
             </a:r>
             <a:endParaRPr lang="en-US" sz="1800" dirty="0"/>
           </a:p>
@@ -2862,7 +2862,7 @@
                 <a:ea typeface="Arial" pitchFamily="34" charset="-122"/>
                 <a:cs typeface="Arial" pitchFamily="34" charset="-120"/>
               </a:rPr>
-              <a:t>3.  Which check would it most likely fail — accuracy, taste or done-ness? Tick one; say what you'd look for.</a:t>
+              <a:t>3.  Which check would it most likely fail — accuracy, taste or done-ness? Check one; say what you'd look for.</a:t>
             </a:r>
             <a:endParaRPr lang="en-US" sz="1800" dirty="0"/>
           </a:p>
@@ -5650,7 +5650,7 @@
               <a:buNone/>
             </a:pPr>
             <a:r>
-              <a:rPr lang="en-US" sz="2600" b="1" dirty="0">
+              <a:rPr lang="en-US" sz="1800" b="1" dirty="0">
                 <a:solidFill>
                   <a:srgbClr val="FFB020"/>
                 </a:solidFill>
@@ -5658,9 +5658,9 @@
                 <a:ea typeface="Arial" pitchFamily="34" charset="-122"/>
                 <a:cs typeface="Arial" pitchFamily="34" charset="-120"/>
               </a:rPr>
-              <a:t>Watch one get fixed</a:t>
-            </a:r>
-            <a:endParaRPr lang="en-US" sz="2600" dirty="0"/>
+              <a:t>Watch one get fixed — "Plan the game night." becomes a quest card</a:t>
+            </a:r>
+            <a:endParaRPr lang="en-US" sz="1800" dirty="0"/>
           </a:p>
         </p:txBody>
       </p:sp>
@@ -5673,11 +5673,11 @@
         <p:spPr>
           <a:xfrm>
             <a:off x="502920" y="1188720"/>
-            <a:ext cx="3931920" cy="3406140"/>
+            <a:ext cx="1863090" cy="3406140"/>
           </a:xfrm>
           <a:prstGeom prst="roundRect">
             <a:avLst>
-              <a:gd name="adj" fmla="val 3758"/>
+              <a:gd name="adj" fmla="val 6871"/>
             </a:avLst>
           </a:prstGeom>
           <a:solidFill>
@@ -5693,102 +5693,22 @@
       </p:sp>
       <p:sp>
         <p:nvSpPr>
-          <p:cNvPr id="7" name="Text 4"/>
-          <p:cNvSpPr txBox="1"/>
-          <p:nvPr/>
-        </p:nvSpPr>
-        <p:spPr>
-          <a:xfrm>
-            <a:off x="731520" y="1371600"/>
-            <a:ext cx="3474720" cy="365760"/>
-          </a:xfrm>
-          <a:prstGeom prst="rect">
-            <a:avLst/>
-          </a:prstGeom>
-          <a:noFill/>
-          <a:ln/>
-        </p:spPr>
-        <p:txBody>
-          <a:bodyPr wrap="square" lIns="0" tIns="0" rIns="0" bIns="0" rtlCol="0" anchor="t"/>
-          <a:lstStyle/>
-          <a:p>
-            <a:pPr indent="0" marL="0">
-              <a:buNone/>
-            </a:pPr>
-            <a:r>
-              <a:rPr lang="en-US" sz="1300" b="1" spc="100" kern="0" dirty="0">
-                <a:solidFill>
-                  <a:srgbClr val="A9A9C4"/>
-                </a:solidFill>
-                <a:latin typeface="Arial" pitchFamily="34" charset="0"/>
-                <a:ea typeface="Arial" pitchFamily="34" charset="-122"/>
-                <a:cs typeface="Arial" pitchFamily="34" charset="-120"/>
-              </a:rPr>
-              <a:t>CURSED ORDER</a:t>
-            </a:r>
-            <a:endParaRPr lang="en-US" sz="1300" dirty="0"/>
-          </a:p>
-        </p:txBody>
-      </p:sp>
-      <p:sp>
-        <p:nvSpPr>
-          <p:cNvPr id="8" name="Text 5"/>
-          <p:cNvSpPr txBox="1"/>
-          <p:nvPr/>
-        </p:nvSpPr>
-        <p:spPr>
-          <a:xfrm>
-            <a:off x="731520" y="1828800"/>
-            <a:ext cx="3474720" cy="2583180"/>
-          </a:xfrm>
-          <a:prstGeom prst="rect">
-            <a:avLst/>
-          </a:prstGeom>
-          <a:noFill/>
-          <a:ln/>
-        </p:spPr>
-        <p:txBody>
-          <a:bodyPr wrap="square" lIns="0" tIns="0" rIns="0" bIns="0" rtlCol="0" anchor="t"/>
-          <a:lstStyle/>
-          <a:p>
-            <a:pPr indent="0" marL="0">
-              <a:buNone/>
-            </a:pPr>
-            <a:r>
-              <a:rPr lang="en-US" sz="1700" dirty="0">
-                <a:solidFill>
-                  <a:srgbClr val="FFFFFF"/>
-                </a:solidFill>
-                <a:latin typeface="Arial" pitchFamily="34" charset="0"/>
-                <a:ea typeface="Arial" pitchFamily="34" charset="-122"/>
-                <a:cs typeface="Arial" pitchFamily="34" charset="-120"/>
-              </a:rPr>
-              <a:t>"Plan the game night."</a:t>
-            </a:r>
-            <a:endParaRPr lang="en-US" sz="1700" dirty="0"/>
-          </a:p>
-        </p:txBody>
-      </p:sp>
-      <p:sp>
-        <p:nvSpPr>
-          <p:cNvPr id="9" name="Shape 6"/>
+          <p:cNvPr id="7" name="Shape 4"/>
           <p:cNvSpPr/>
           <p:nvPr/>
         </p:nvSpPr>
         <p:spPr>
           <a:xfrm>
-            <a:off x="4709160" y="1188720"/>
-            <a:ext cx="3931920" cy="3406140"/>
-          </a:xfrm>
-          <a:prstGeom prst="roundRect">
-            <a:avLst>
-              <a:gd name="adj" fmla="val 3758"/>
-            </a:avLst>
+            <a:off x="731520" y="1417320"/>
+            <a:ext cx="502920" cy="502920"/>
+          </a:xfrm>
+          <a:prstGeom prst="ellipse">
+            <a:avLst/>
           </a:prstGeom>
           <a:solidFill>
-            <a:srgbClr val="2F2A5C"/>
+            <a:srgbClr val="FFB020"/>
           </a:solidFill>
-          <a:ln w="19050">
+          <a:ln w="12700">
             <a:solidFill>
               <a:srgbClr val="FFB020"/>
             </a:solidFill>
@@ -5798,14 +5718,92 @@
       </p:sp>
       <p:sp>
         <p:nvSpPr>
+          <p:cNvPr id="8" name="Text 5"/>
+          <p:cNvSpPr txBox="1"/>
+          <p:nvPr/>
+        </p:nvSpPr>
+        <p:spPr>
+          <a:xfrm>
+            <a:off x="731520" y="1417320"/>
+            <a:ext cx="502920" cy="502920"/>
+          </a:xfrm>
+          <a:prstGeom prst="rect">
+            <a:avLst/>
+          </a:prstGeom>
+          <a:noFill/>
+          <a:ln/>
+        </p:spPr>
+        <p:txBody>
+          <a:bodyPr wrap="square" lIns="0" tIns="0" rIns="0" bIns="0" rtlCol="0" anchor="ctr"/>
+          <a:lstStyle/>
+          <a:p>
+            <a:pPr algn="ctr" indent="0" marL="0">
+              <a:buNone/>
+            </a:pPr>
+            <a:r>
+              <a:rPr lang="en-US" sz="1600" b="1" dirty="0">
+                <a:solidFill>
+                  <a:srgbClr val="14141F"/>
+                </a:solidFill>
+                <a:latin typeface="Arial" pitchFamily="34" charset="0"/>
+                <a:ea typeface="Arial" pitchFamily="34" charset="-122"/>
+                <a:cs typeface="Arial" pitchFamily="34" charset="-120"/>
+              </a:rPr>
+              <a:t>G</a:t>
+            </a:r>
+            <a:endParaRPr lang="en-US" sz="1600" dirty="0"/>
+          </a:p>
+        </p:txBody>
+      </p:sp>
+      <p:sp>
+        <p:nvSpPr>
+          <p:cNvPr id="9" name="Text 6"/>
+          <p:cNvSpPr txBox="1"/>
+          <p:nvPr/>
+        </p:nvSpPr>
+        <p:spPr>
+          <a:xfrm>
+            <a:off x="731520" y="2057400"/>
+            <a:ext cx="1405890" cy="457200"/>
+          </a:xfrm>
+          <a:prstGeom prst="rect">
+            <a:avLst/>
+          </a:prstGeom>
+          <a:noFill/>
+          <a:ln/>
+        </p:spPr>
+        <p:txBody>
+          <a:bodyPr wrap="square" lIns="0" tIns="0" rIns="0" bIns="0" rtlCol="0" anchor="ctr"/>
+          <a:lstStyle/>
+          <a:p>
+            <a:pPr indent="0" marL="0">
+              <a:buNone/>
+            </a:pPr>
+            <a:r>
+              <a:rPr lang="en-US" sz="1700" b="1" dirty="0">
+                <a:solidFill>
+                  <a:srgbClr val="FFB020"/>
+                </a:solidFill>
+                <a:latin typeface="Arial" pitchFamily="34" charset="0"/>
+                <a:ea typeface="Arial" pitchFamily="34" charset="-122"/>
+                <a:cs typeface="Arial" pitchFamily="34" charset="-120"/>
+              </a:rPr>
+              <a:t>Goal</a:t>
+            </a:r>
+            <a:endParaRPr lang="en-US" sz="1700" dirty="0"/>
+          </a:p>
+        </p:txBody>
+      </p:sp>
+      <p:sp>
+        <p:nvSpPr>
           <p:cNvPr id="10" name="Text 7"/>
           <p:cNvSpPr txBox="1"/>
           <p:nvPr/>
         </p:nvSpPr>
         <p:spPr>
           <a:xfrm>
-            <a:off x="4937760" y="1371600"/>
-            <a:ext cx="3474720" cy="365760"/>
+            <a:off x="731520" y="2560320"/>
+            <a:ext cx="1405890" cy="1805940"/>
           </a:xfrm>
           <a:prstGeom prst="rect">
             <a:avLst/>
@@ -5821,7 +5819,137 @@
               <a:buNone/>
             </a:pPr>
             <a:r>
-              <a:rPr lang="en-US" sz="1300" b="1" spc="100" kern="0" dirty="0">
+              <a:rPr lang="en-US" sz="1400" dirty="0">
+                <a:solidFill>
+                  <a:srgbClr val="E8E8F5"/>
+                </a:solidFill>
+                <a:latin typeface="Arial" pitchFamily="34" charset="0"/>
+                <a:ea typeface="Arial" pitchFamily="34" charset="-122"/>
+                <a:cs typeface="Arial" pitchFamily="34" charset="-120"/>
+              </a:rPr>
+              <a:t>get 6th graders to actually show up to Game Night.</a:t>
+            </a:r>
+            <a:endParaRPr lang="en-US" sz="1400" dirty="0"/>
+          </a:p>
+        </p:txBody>
+      </p:sp>
+      <p:sp>
+        <p:nvSpPr>
+          <p:cNvPr id="11" name="Shape 8"/>
+          <p:cNvSpPr/>
+          <p:nvPr/>
+        </p:nvSpPr>
+        <p:spPr>
+          <a:xfrm>
+            <a:off x="2594610" y="1188720"/>
+            <a:ext cx="1863090" cy="3406140"/>
+          </a:xfrm>
+          <a:prstGeom prst="roundRect">
+            <a:avLst>
+              <a:gd name="adj" fmla="val 6871"/>
+            </a:avLst>
+          </a:prstGeom>
+          <a:solidFill>
+            <a:srgbClr val="262648"/>
+          </a:solidFill>
+          <a:ln w="12700">
+            <a:solidFill>
+              <a:srgbClr val="262648"/>
+            </a:solidFill>
+            <a:prstDash val="solid"/>
+          </a:ln>
+        </p:spPr>
+      </p:sp>
+      <p:sp>
+        <p:nvSpPr>
+          <p:cNvPr id="12" name="Shape 9"/>
+          <p:cNvSpPr/>
+          <p:nvPr/>
+        </p:nvSpPr>
+        <p:spPr>
+          <a:xfrm>
+            <a:off x="2823210" y="1417320"/>
+            <a:ext cx="502920" cy="502920"/>
+          </a:xfrm>
+          <a:prstGeom prst="ellipse">
+            <a:avLst/>
+          </a:prstGeom>
+          <a:solidFill>
+            <a:srgbClr val="FFB020"/>
+          </a:solidFill>
+          <a:ln w="12700">
+            <a:solidFill>
+              <a:srgbClr val="FFB020"/>
+            </a:solidFill>
+            <a:prstDash val="solid"/>
+          </a:ln>
+        </p:spPr>
+      </p:sp>
+      <p:sp>
+        <p:nvSpPr>
+          <p:cNvPr id="13" name="Text 10"/>
+          <p:cNvSpPr txBox="1"/>
+          <p:nvPr/>
+        </p:nvSpPr>
+        <p:spPr>
+          <a:xfrm>
+            <a:off x="2823210" y="1417320"/>
+            <a:ext cx="502920" cy="502920"/>
+          </a:xfrm>
+          <a:prstGeom prst="rect">
+            <a:avLst/>
+          </a:prstGeom>
+          <a:noFill/>
+          <a:ln/>
+        </p:spPr>
+        <p:txBody>
+          <a:bodyPr wrap="square" lIns="0" tIns="0" rIns="0" bIns="0" rtlCol="0" anchor="ctr"/>
+          <a:lstStyle/>
+          <a:p>
+            <a:pPr algn="ctr" indent="0" marL="0">
+              <a:buNone/>
+            </a:pPr>
+            <a:r>
+              <a:rPr lang="en-US" sz="1600" b="1" dirty="0">
+                <a:solidFill>
+                  <a:srgbClr val="14141F"/>
+                </a:solidFill>
+                <a:latin typeface="Arial" pitchFamily="34" charset="0"/>
+                <a:ea typeface="Arial" pitchFamily="34" charset="-122"/>
+                <a:cs typeface="Arial" pitchFamily="34" charset="-120"/>
+              </a:rPr>
+              <a:t>K</a:t>
+            </a:r>
+            <a:endParaRPr lang="en-US" sz="1600" dirty="0"/>
+          </a:p>
+        </p:txBody>
+      </p:sp>
+      <p:sp>
+        <p:nvSpPr>
+          <p:cNvPr id="14" name="Text 11"/>
+          <p:cNvSpPr txBox="1"/>
+          <p:nvPr/>
+        </p:nvSpPr>
+        <p:spPr>
+          <a:xfrm>
+            <a:off x="2823210" y="2057400"/>
+            <a:ext cx="1405890" cy="457200"/>
+          </a:xfrm>
+          <a:prstGeom prst="rect">
+            <a:avLst/>
+          </a:prstGeom>
+          <a:noFill/>
+          <a:ln/>
+        </p:spPr>
+        <p:txBody>
+          <a:bodyPr wrap="square" lIns="0" tIns="0" rIns="0" bIns="0" rtlCol="0" anchor="ctr"/>
+          <a:lstStyle/>
+          <a:p>
+            <a:pPr indent="0" marL="0">
+              <a:buNone/>
+            </a:pPr>
+            <a:r>
+              <a:rPr lang="en-US" sz="1400" b="1" dirty="0">
                 <a:solidFill>
                   <a:srgbClr val="FFB020"/>
                 </a:solidFill>
@@ -5829,22 +5957,22 @@
                 <a:ea typeface="Arial" pitchFamily="34" charset="-122"/>
                 <a:cs typeface="Arial" pitchFamily="34" charset="-120"/>
               </a:rPr>
-              <a:t>PARTY LEADER'S QUEST CARD</a:t>
-            </a:r>
-            <a:endParaRPr lang="en-US" sz="1300" dirty="0"/>
-          </a:p>
-        </p:txBody>
-      </p:sp>
-      <p:sp>
-        <p:nvSpPr>
-          <p:cNvPr id="11" name="Text 8"/>
-          <p:cNvSpPr txBox="1"/>
-          <p:nvPr/>
-        </p:nvSpPr>
-        <p:spPr>
-          <a:xfrm>
-            <a:off x="4937760" y="1828800"/>
-            <a:ext cx="3474720" cy="2583180"/>
+              <a:t>What We Know</a:t>
+            </a:r>
+            <a:endParaRPr lang="en-US" sz="1400" dirty="0"/>
+          </a:p>
+        </p:txBody>
+      </p:sp>
+      <p:sp>
+        <p:nvSpPr>
+          <p:cNvPr id="15" name="Text 12"/>
+          <p:cNvSpPr txBox="1"/>
+          <p:nvPr/>
+        </p:nvSpPr>
+        <p:spPr>
+          <a:xfrm>
+            <a:off x="2823210" y="2560320"/>
+            <a:ext cx="1405890" cy="1805940"/>
           </a:xfrm>
           <a:prstGeom prst="rect">
             <a:avLst/>
@@ -5860,17 +5988,355 @@
               <a:buNone/>
             </a:pPr>
             <a:r>
-              <a:rPr lang="en-US" sz="1700" dirty="0">
-                <a:solidFill>
-                  <a:srgbClr val="FFFFFF"/>
-                </a:solidFill>
-                <a:latin typeface="Arial" pitchFamily="34" charset="0"/>
-                <a:ea typeface="Arial" pitchFamily="34" charset="-122"/>
-                <a:cs typeface="Arial" pitchFamily="34" charset="-120"/>
-              </a:rPr>
-              <a:t>GOAL: get 6th graders to show up. WHAT WE KNOW: Friday, gym, 6–8 pm; board games, two TVs. RULES: school-appropriate, big title, 40 words max. DONE: one flyer draft.</a:t>
-            </a:r>
-            <a:endParaRPr lang="en-US" sz="1700" dirty="0"/>
+              <a:rPr lang="en-US" sz="1400" dirty="0">
+                <a:solidFill>
+                  <a:srgbClr val="E8E8F5"/>
+                </a:solidFill>
+                <a:latin typeface="Arial" pitchFamily="34" charset="0"/>
+                <a:ea typeface="Arial" pitchFamily="34" charset="-122"/>
+                <a:cs typeface="Arial" pitchFamily="34" charset="-120"/>
+              </a:rPr>
+              <a:t>Friday, gym, 6–8 pm; we have board games and two TVs.</a:t>
+            </a:r>
+            <a:endParaRPr lang="en-US" sz="1400" dirty="0"/>
+          </a:p>
+        </p:txBody>
+      </p:sp>
+      <p:sp>
+        <p:nvSpPr>
+          <p:cNvPr id="16" name="Shape 13"/>
+          <p:cNvSpPr/>
+          <p:nvPr/>
+        </p:nvSpPr>
+        <p:spPr>
+          <a:xfrm>
+            <a:off x="4686300" y="1188720"/>
+            <a:ext cx="1863090" cy="3406140"/>
+          </a:xfrm>
+          <a:prstGeom prst="roundRect">
+            <a:avLst>
+              <a:gd name="adj" fmla="val 6871"/>
+            </a:avLst>
+          </a:prstGeom>
+          <a:solidFill>
+            <a:srgbClr val="262648"/>
+          </a:solidFill>
+          <a:ln w="12700">
+            <a:solidFill>
+              <a:srgbClr val="262648"/>
+            </a:solidFill>
+            <a:prstDash val="solid"/>
+          </a:ln>
+        </p:spPr>
+      </p:sp>
+      <p:sp>
+        <p:nvSpPr>
+          <p:cNvPr id="17" name="Shape 14"/>
+          <p:cNvSpPr/>
+          <p:nvPr/>
+        </p:nvSpPr>
+        <p:spPr>
+          <a:xfrm>
+            <a:off x="4914900" y="1417320"/>
+            <a:ext cx="502920" cy="502920"/>
+          </a:xfrm>
+          <a:prstGeom prst="ellipse">
+            <a:avLst/>
+          </a:prstGeom>
+          <a:solidFill>
+            <a:srgbClr val="FFB020"/>
+          </a:solidFill>
+          <a:ln w="12700">
+            <a:solidFill>
+              <a:srgbClr val="FFB020"/>
+            </a:solidFill>
+            <a:prstDash val="solid"/>
+          </a:ln>
+        </p:spPr>
+      </p:sp>
+      <p:sp>
+        <p:nvSpPr>
+          <p:cNvPr id="18" name="Text 15"/>
+          <p:cNvSpPr txBox="1"/>
+          <p:nvPr/>
+        </p:nvSpPr>
+        <p:spPr>
+          <a:xfrm>
+            <a:off x="4914900" y="1417320"/>
+            <a:ext cx="502920" cy="502920"/>
+          </a:xfrm>
+          <a:prstGeom prst="rect">
+            <a:avLst/>
+          </a:prstGeom>
+          <a:noFill/>
+          <a:ln/>
+        </p:spPr>
+        <p:txBody>
+          <a:bodyPr wrap="square" lIns="0" tIns="0" rIns="0" bIns="0" rtlCol="0" anchor="ctr"/>
+          <a:lstStyle/>
+          <a:p>
+            <a:pPr algn="ctr" indent="0" marL="0">
+              <a:buNone/>
+            </a:pPr>
+            <a:r>
+              <a:rPr lang="en-US" sz="1600" b="1" dirty="0">
+                <a:solidFill>
+                  <a:srgbClr val="14141F"/>
+                </a:solidFill>
+                <a:latin typeface="Arial" pitchFamily="34" charset="0"/>
+                <a:ea typeface="Arial" pitchFamily="34" charset="-122"/>
+                <a:cs typeface="Arial" pitchFamily="34" charset="-120"/>
+              </a:rPr>
+              <a:t>R</a:t>
+            </a:r>
+            <a:endParaRPr lang="en-US" sz="1600" dirty="0"/>
+          </a:p>
+        </p:txBody>
+      </p:sp>
+      <p:sp>
+        <p:nvSpPr>
+          <p:cNvPr id="19" name="Text 16"/>
+          <p:cNvSpPr txBox="1"/>
+          <p:nvPr/>
+        </p:nvSpPr>
+        <p:spPr>
+          <a:xfrm>
+            <a:off x="4914900" y="2057400"/>
+            <a:ext cx="1405890" cy="457200"/>
+          </a:xfrm>
+          <a:prstGeom prst="rect">
+            <a:avLst/>
+          </a:prstGeom>
+          <a:noFill/>
+          <a:ln/>
+        </p:spPr>
+        <p:txBody>
+          <a:bodyPr wrap="square" lIns="0" tIns="0" rIns="0" bIns="0" rtlCol="0" anchor="ctr"/>
+          <a:lstStyle/>
+          <a:p>
+            <a:pPr indent="0" marL="0">
+              <a:buNone/>
+            </a:pPr>
+            <a:r>
+              <a:rPr lang="en-US" sz="1400" b="1" dirty="0">
+                <a:solidFill>
+                  <a:srgbClr val="FFB020"/>
+                </a:solidFill>
+                <a:latin typeface="Arial" pitchFamily="34" charset="0"/>
+                <a:ea typeface="Arial" pitchFamily="34" charset="-122"/>
+                <a:cs typeface="Arial" pitchFamily="34" charset="-120"/>
+              </a:rPr>
+              <a:t>Rules of the Run</a:t>
+            </a:r>
+            <a:endParaRPr lang="en-US" sz="1400" dirty="0"/>
+          </a:p>
+        </p:txBody>
+      </p:sp>
+      <p:sp>
+        <p:nvSpPr>
+          <p:cNvPr id="20" name="Text 17"/>
+          <p:cNvSpPr txBox="1"/>
+          <p:nvPr/>
+        </p:nvSpPr>
+        <p:spPr>
+          <a:xfrm>
+            <a:off x="4914900" y="2560320"/>
+            <a:ext cx="1405890" cy="1805940"/>
+          </a:xfrm>
+          <a:prstGeom prst="rect">
+            <a:avLst/>
+          </a:prstGeom>
+          <a:noFill/>
+          <a:ln/>
+        </p:spPr>
+        <p:txBody>
+          <a:bodyPr wrap="square" lIns="0" tIns="0" rIns="0" bIns="0" rtlCol="0" anchor="t"/>
+          <a:lstStyle/>
+          <a:p>
+            <a:pPr indent="0" marL="0">
+              <a:buNone/>
+            </a:pPr>
+            <a:r>
+              <a:rPr lang="en-US" sz="1400" dirty="0">
+                <a:solidFill>
+                  <a:srgbClr val="E8E8F5"/>
+                </a:solidFill>
+                <a:latin typeface="Arial" pitchFamily="34" charset="0"/>
+                <a:ea typeface="Arial" pitchFamily="34" charset="-122"/>
+                <a:cs typeface="Arial" pitchFamily="34" charset="-120"/>
+              </a:rPr>
+              <a:t>school-appropriate, big readable title, 40 words max.</a:t>
+            </a:r>
+            <a:endParaRPr lang="en-US" sz="1400" dirty="0"/>
+          </a:p>
+        </p:txBody>
+      </p:sp>
+      <p:sp>
+        <p:nvSpPr>
+          <p:cNvPr id="21" name="Shape 18"/>
+          <p:cNvSpPr/>
+          <p:nvPr/>
+        </p:nvSpPr>
+        <p:spPr>
+          <a:xfrm>
+            <a:off x="6777990" y="1188720"/>
+            <a:ext cx="1863090" cy="3406140"/>
+          </a:xfrm>
+          <a:prstGeom prst="roundRect">
+            <a:avLst>
+              <a:gd name="adj" fmla="val 6871"/>
+            </a:avLst>
+          </a:prstGeom>
+          <a:solidFill>
+            <a:srgbClr val="262648"/>
+          </a:solidFill>
+          <a:ln w="12700">
+            <a:solidFill>
+              <a:srgbClr val="262648"/>
+            </a:solidFill>
+            <a:prstDash val="solid"/>
+          </a:ln>
+        </p:spPr>
+      </p:sp>
+      <p:sp>
+        <p:nvSpPr>
+          <p:cNvPr id="22" name="Shape 19"/>
+          <p:cNvSpPr/>
+          <p:nvPr/>
+        </p:nvSpPr>
+        <p:spPr>
+          <a:xfrm>
+            <a:off x="7006590" y="1417320"/>
+            <a:ext cx="502920" cy="502920"/>
+          </a:xfrm>
+          <a:prstGeom prst="ellipse">
+            <a:avLst/>
+          </a:prstGeom>
+          <a:solidFill>
+            <a:srgbClr val="FFB020"/>
+          </a:solidFill>
+          <a:ln w="12700">
+            <a:solidFill>
+              <a:srgbClr val="FFB020"/>
+            </a:solidFill>
+            <a:prstDash val="solid"/>
+          </a:ln>
+        </p:spPr>
+      </p:sp>
+      <p:sp>
+        <p:nvSpPr>
+          <p:cNvPr id="23" name="Text 20"/>
+          <p:cNvSpPr txBox="1"/>
+          <p:nvPr/>
+        </p:nvSpPr>
+        <p:spPr>
+          <a:xfrm>
+            <a:off x="7006590" y="1417320"/>
+            <a:ext cx="502920" cy="502920"/>
+          </a:xfrm>
+          <a:prstGeom prst="rect">
+            <a:avLst/>
+          </a:prstGeom>
+          <a:noFill/>
+          <a:ln/>
+        </p:spPr>
+        <p:txBody>
+          <a:bodyPr wrap="square" lIns="0" tIns="0" rIns="0" bIns="0" rtlCol="0" anchor="ctr"/>
+          <a:lstStyle/>
+          <a:p>
+            <a:pPr algn="ctr" indent="0" marL="0">
+              <a:buNone/>
+            </a:pPr>
+            <a:r>
+              <a:rPr lang="en-US" sz="1600" b="1" dirty="0">
+                <a:solidFill>
+                  <a:srgbClr val="14141F"/>
+                </a:solidFill>
+                <a:latin typeface="Arial" pitchFamily="34" charset="0"/>
+                <a:ea typeface="Arial" pitchFamily="34" charset="-122"/>
+                <a:cs typeface="Arial" pitchFamily="34" charset="-120"/>
+              </a:rPr>
+              <a:t>D</a:t>
+            </a:r>
+            <a:endParaRPr lang="en-US" sz="1600" dirty="0"/>
+          </a:p>
+        </p:txBody>
+      </p:sp>
+      <p:sp>
+        <p:nvSpPr>
+          <p:cNvPr id="24" name="Text 21"/>
+          <p:cNvSpPr txBox="1"/>
+          <p:nvPr/>
+        </p:nvSpPr>
+        <p:spPr>
+          <a:xfrm>
+            <a:off x="7006590" y="2057400"/>
+            <a:ext cx="1405890" cy="457200"/>
+          </a:xfrm>
+          <a:prstGeom prst="rect">
+            <a:avLst/>
+          </a:prstGeom>
+          <a:noFill/>
+          <a:ln/>
+        </p:spPr>
+        <p:txBody>
+          <a:bodyPr wrap="square" lIns="0" tIns="0" rIns="0" bIns="0" rtlCol="0" anchor="ctr"/>
+          <a:lstStyle/>
+          <a:p>
+            <a:pPr indent="0" marL="0">
+              <a:buNone/>
+            </a:pPr>
+            <a:r>
+              <a:rPr lang="en-US" sz="1400" b="1" dirty="0">
+                <a:solidFill>
+                  <a:srgbClr val="FFB020"/>
+                </a:solidFill>
+                <a:latin typeface="Arial" pitchFamily="34" charset="0"/>
+                <a:ea typeface="Arial" pitchFamily="34" charset="-122"/>
+                <a:cs typeface="Arial" pitchFamily="34" charset="-120"/>
+              </a:rPr>
+              <a:t>Done Looks Like</a:t>
+            </a:r>
+            <a:endParaRPr lang="en-US" sz="1400" dirty="0"/>
+          </a:p>
+        </p:txBody>
+      </p:sp>
+      <p:sp>
+        <p:nvSpPr>
+          <p:cNvPr id="25" name="Text 22"/>
+          <p:cNvSpPr txBox="1"/>
+          <p:nvPr/>
+        </p:nvSpPr>
+        <p:spPr>
+          <a:xfrm>
+            <a:off x="7006590" y="2560320"/>
+            <a:ext cx="1405890" cy="1805940"/>
+          </a:xfrm>
+          <a:prstGeom prst="rect">
+            <a:avLst/>
+          </a:prstGeom>
+          <a:noFill/>
+          <a:ln/>
+        </p:spPr>
+        <p:txBody>
+          <a:bodyPr wrap="square" lIns="0" tIns="0" rIns="0" bIns="0" rtlCol="0" anchor="t"/>
+          <a:lstStyle/>
+          <a:p>
+            <a:pPr indent="0" marL="0">
+              <a:buNone/>
+            </a:pPr>
+            <a:r>
+              <a:rPr lang="en-US" sz="1400" dirty="0">
+                <a:solidFill>
+                  <a:srgbClr val="E8E8F5"/>
+                </a:solidFill>
+                <a:latin typeface="Arial" pitchFamily="34" charset="0"/>
+                <a:ea typeface="Arial" pitchFamily="34" charset="-122"/>
+                <a:cs typeface="Arial" pitchFamily="34" charset="-120"/>
+              </a:rPr>
+              <a:t>one flyer draft, ready to photocopy.</a:t>
+            </a:r>
+            <a:endParaRPr lang="en-US" sz="1400" dirty="0"/>
           </a:p>
         </p:txBody>
       </p:sp>
@@ -6413,7 +6879,7 @@
                 <a:ea typeface="Arial" pitchFamily="34" charset="-122"/>
                 <a:cs typeface="Arial" pitchFamily="34" charset="-120"/>
               </a:rPr>
-              <a:t>Turn the card into a numbered step list with a time guess per step. Card silent on something? Write "NOT ON THE CARD" — don't guess.</a:t>
+              <a:t>Minutes 0–4: a numbered step list. Card silent? Write "NOT ON THE CARD." Minutes 4–8: a time guess per step; star the riskiest.</a:t>
             </a:r>
             <a:endParaRPr lang="en-US" sz="1400" dirty="0"/>
           </a:p>
@@ -6751,7 +7217,7 @@
                 <a:ea typeface="Arial" pitchFamily="34" charset="-122"/>
                 <a:cs typeface="Arial" pitchFamily="34" charset="-120"/>
               </a:rPr>
-              <a:t>Read the card as the audience. At the 4-minute call, read the Planner's list and write 3 upgrades to that plan. "Make it better" is banned.</a:t>
+              <a:t>Minutes 0–4: write 2 things the audience on the card cares about. At the 4-minute call, read the Planner's list; write 3 upgrades.</a:t>
             </a:r>
             <a:endParaRPr lang="en-US" sz="1400" dirty="0"/>
           </a:p>
@@ -7250,7 +7716,7 @@
                 <a:ea typeface="Arial" pitchFamily="34" charset="-122"/>
                 <a:cs typeface="Arial" pitchFamily="34" charset="-120"/>
               </a:rPr>
-              <a:t>Now switch: YOU play an AI agent. Take a role card and work SILENTLY, from the card alone, on your own paper. No questions — agents can't read minds.</a:t>
+              <a:t>Now switch: YOU play an AI agent. Take a role card; work SILENTLY on your own paper. Papers stay put. No questions — agents can't read minds.</a:t>
             </a:r>
             <a:endParaRPr lang="en-US" sz="1300" dirty="0"/>
           </a:p>
@@ -7392,7 +7858,7 @@
                 <a:ea typeface="Arial" pitchFamily="34" charset="-122"/>
                 <a:cs typeface="Arial" pitchFamily="34" charset="-120"/>
               </a:rPr>
-              <a:t>Pass your paper one seat left — you're the leader again. Run the CHECK rubric on one party member's work: SHIP IT or RUN IT BACK, then the note.</a:t>
+              <a:t>Everyone passes their OWN paper one seat left — you're the leader again. Run the CHECK rubric: SHIP IT or RUN IT BACK per check, then the note.</a:t>
             </a:r>
             <a:endParaRPr lang="en-US" sz="1300" dirty="0"/>
           </a:p>

</xml_diff>

<commit_message>
Gauntlet R2 wave 3: preview band fits + PREVIEW tag, bundle preview with student pages, bundle Save 30% title/badge, nine-code standards (bundle exemption in validate), L4 sentence two, through-line in L4/L6, cover CSS unified, art polish, sheets regenerated
Co-Authored-By: Claude Fable 5.1 <noreply@anthropic.com>
Claude-Session: https://claude.ai/code/session_01VWaJFc84eoA3U4f2VjTKjw
</commit_message>
<xml_diff>
--- a/products/ai-agent-intern/dist/Lead Your AI Squad - Slides.pptx
+++ b/products/ai-agent-intern/dist/Lead Your AI Squad - Slides.pptx
@@ -777,7 +777,7 @@
           <a:p>
             <a:r>
               <a:rPr lang="en-US" dirty="0"/>
-              <a:t>Close on this — it's the leader rule from the bottom of the worksheet. This is Lesson 6 of 6; the unit ends here, and every lesson stands alone. (If your class did the earlier lessons: the quest card is the genie-proof prompt, the accuracy check is the fact desk, the taste check is the feedback eye — they had the skills; today they found out the skills make them a leader.) With devices: the five-line block in the lesson plan runs one team's card on your projected account and the class checks its output with the same rubric. Hedge if asked about jobs: AI agents take over tasks, not whole jobs — nobody can promise the final count.</a:t>
+              <a:t>Close on this — it's the leader rule from the bottom of the worksheet. This is Lesson 6 of 6 (Lesson 6 — in the unit bundle, or sold separately); the unit ends here, and every lesson stands alone. (If your class did the earlier lessons: the quest card is the genie-proof prompt, the accuracy check is the fact desk, the taste check is the feedback eye — they had the skills; today they found out the skills make them a leader.) With devices: the five-line block in the lesson plan runs one team's card on your projected account and the class checks its output with the same rubric. Hedge if asked about jobs: AI agents take over tasks, not whole jobs — nobody can promise the final count.</a:t>
             </a:r>
             <a:endParaRPr lang="en-US" dirty="0"/>
           </a:p>
@@ -3075,7 +3075,7 @@
                 <a:ea typeface="Arial" pitchFamily="34" charset="-122"/>
                 <a:cs typeface="Arial" pitchFamily="34" charset="-120"/>
               </a:rPr>
-              <a:t>If wrong facts ship, the leader signed off. Check like it matters.</a:t>
+              <a:t>Every AI job runs human → AI → human: you write the card, the AI does the middle, you check the loot. If wrong facts ship, the leader signed off.</a:t>
             </a:r>
             <a:endParaRPr lang="en-US" sz="1600" dirty="0"/>
           </a:p>

</xml_diff>

<commit_message>
Student-read fixes: L4 tone words glossed + four-sentence panel, L5 claim-first Defend It with 'because' cue, L6 blank sheet not the worksheet + plain agent definition + party on student pages
Co-Authored-By: Claude Opus 5 <noreply@anthropic.com>
Claude-Session: https://claude.ai/code/session_01VWaJFc84eoA3U4f2VjTKjw
</commit_message>
<xml_diff>
--- a/products/ai-agent-intern/dist/Lead Your AI Squad - Slides.pptx
+++ b/products/ai-agent-intern/dist/Lead Your AI Squad - Slides.pptx
@@ -1041,7 +1041,7 @@
           <a:p>
             <a:r>
               <a:rPr lang="en-US" dirty="0"/>
-              <a:t>Write the loop on the board as you go: QUEST CARD → ROLES → CHECK THE LOOT → SHIP IT or RUN IT BACK. Gloss the two verdicts out loud the first time: SHIP IT = good to go; RUN IT BACK = do it again. Each part gets its own slide next; this one is the map.</a:t>
+              <a:t>Write the loop on the board as you go: QUEST CARD → ROLES → CHECK THE LOOT → SHIP IT or RUN IT BACK. Gloss the two verdicts out loud the first time: SHIP IT = finished and correct, send it; RUN IT BACK = do it again. Each part gets its own slide next; this one is the map.</a:t>
             </a:r>
             <a:endParaRPr lang="en-US" dirty="0"/>
           </a:p>
@@ -2067,7 +2067,7 @@
                 <a:ea typeface="Arial" pitchFamily="34" charset="-122"/>
                 <a:cs typeface="Arial" pitchFamily="34" charset="-120"/>
               </a:rPr>
-              <a:t>An AI agent does a multi-step job on its own — and where your card is vague, it guesses forward. Party leaders don't redo the squad's work: they write the quest card, hand out the roles, and check the loot.</a:t>
+              <a:t>An AI agent does a whole job, step by step, on its own — and if your card leaves something out, the agent just guesses and keeps going. Party leaders don't redo the party's work: they write the quest card, hand out the roles, and check the loot.</a:t>
             </a:r>
             <a:endParaRPr lang="en-US" sz="1200" dirty="0"/>
           </a:p>
@@ -2478,7 +2478,7 @@
                 <a:ea typeface="Arial" pitchFamily="34" charset="-122"/>
                 <a:cs typeface="Arial" pitchFamily="34" charset="-120"/>
               </a:rPr>
-              <a:t>TASTE — Does it fit the audience and tone on the card, or could it be for anybody?</a:t>
+              <a:t>TASTE — Does it fit the audience and tone on the card, or could it be for anyone at all?</a:t>
             </a:r>
             <a:endParaRPr lang="en-US" sz="1800" dirty="0"/>
           </a:p>
@@ -2520,7 +2520,7 @@
                 <a:ea typeface="Arial" pitchFamily="34" charset="-122"/>
                 <a:cs typeface="Arial" pitchFamily="34" charset="-120"/>
               </a:rPr>
-              <a:t>Each check: SHIP IT (good to go) or RUN IT BACK (do it again). Quote the evidence.</a:t>
+              <a:t>Each row: SHIP IT (finished and correct — send it) or RUN IT BACK (do it again). Quote the evidence.</a:t>
             </a:r>
             <a:endParaRPr lang="en-US" sz="1800" dirty="0"/>
           </a:p>
@@ -3036,7 +3036,7 @@
                 <a:ea typeface="Arial" pitchFamily="34" charset="-122"/>
                 <a:cs typeface="Arial" pitchFamily="34" charset="-120"/>
               </a:rPr>
-              <a:t>Your squad is tireless. The name on the quest is YOURS.</a:t>
+              <a:t>Your party is tireless. The name on the quest is YOURS.</a:t>
             </a:r>
             <a:endParaRPr lang="en-US" sz="3400" dirty="0"/>
           </a:p>
@@ -3075,7 +3075,7 @@
                 <a:ea typeface="Arial" pitchFamily="34" charset="-122"/>
                 <a:cs typeface="Arial" pitchFamily="34" charset="-120"/>
               </a:rPr>
-              <a:t>Every AI job runs human → AI → human: you write the card, the AI does the middle, you check the loot. If wrong facts ship, the leader signed off.</a:t>
+              <a:t>Every AI job runs human → AI → human: you write the card, the AI does the middle, you check the loot. If wrong facts ship, the leader said yes to it.</a:t>
             </a:r>
             <a:endParaRPr lang="en-US" sz="1600" dirty="0"/>
           </a:p>
@@ -3793,7 +3793,7 @@
                 <a:ea typeface="Arial" pitchFamily="34" charset="-122"/>
                 <a:cs typeface="Arial" pitchFamily="34" charset="-120"/>
               </a:rPr>
-              <a:t>An AI agent does a multi-step job on its own — and where your card is vague, it guesses forward.</a:t>
+              <a:t>An AI agent does a whole job, step by step, on its own — and if your card leaves something out, the agent just guesses and keeps going.</a:t>
             </a:r>
             <a:endParaRPr lang="en-US" sz="1600" dirty="0"/>
           </a:p>
@@ -4177,7 +4177,7 @@
                 <a:ea typeface="Arial" pitchFamily="34" charset="-122"/>
                 <a:cs typeface="Arial" pitchFamily="34" charset="-120"/>
               </a:rPr>
-              <a:t>Write the job down, all four parts. A vague card makes the squad guess — and guess wrong.</a:t>
+              <a:t>Write the job down, all four parts. Leave something out and the party guesses — wrong.</a:t>
             </a:r>
             <a:endParaRPr lang="en-US" sz="1400" dirty="0"/>
           </a:p>
@@ -4684,7 +4684,7 @@
                 <a:ea typeface="Arial" pitchFamily="34" charset="-122"/>
                 <a:cs typeface="Arial" pitchFamily="34" charset="-120"/>
               </a:rPr>
-              <a:t>SHIP IT (good to go) or RUN IT BACK (do it again) — with a keep + fix note, specific.</a:t>
+              <a:t>SHIP IT (finished and correct — send it) or RUN IT BACK (do it again) + a keep/fix note.</a:t>
             </a:r>
             <a:endParaRPr lang="en-US" sz="1400" dirty="0"/>
           </a:p>
@@ -6710,7 +6710,7 @@
                 <a:ea typeface="Arial" pitchFamily="34" charset="-122"/>
                 <a:cs typeface="Arial" pitchFamily="34" charset="-120"/>
               </a:rPr>
-              <a:t>Squad Roles — Same Card, One Slice Each</a:t>
+              <a:t>Party Roles — Same Card, One Slice Each</a:t>
             </a:r>
             <a:endParaRPr lang="en-US" sz="2300" dirty="0"/>
           </a:p>
@@ -7217,7 +7217,7 @@
                 <a:ea typeface="Arial" pitchFamily="34" charset="-122"/>
                 <a:cs typeface="Arial" pitchFamily="34" charset="-120"/>
               </a:rPr>
-              <a:t>Minutes 0–4: write 2 things the audience on the card cares about. At the 4-minute call, read the Planner's list; write 3 upgrades.</a:t>
+              <a:t>0–4 min: write 2 things the audience on the card cares about. When the teacher calls 4 min, read the Planner's list; write 3 upgrades.</a:t>
             </a:r>
             <a:endParaRPr lang="en-US" sz="1400" dirty="0"/>
           </a:p>
@@ -7677,7 +7677,7 @@
                 <a:ea typeface="Arial" pitchFamily="34" charset="-122"/>
                 <a:cs typeface="Arial" pitchFamily="34" charset="-120"/>
               </a:rPr>
-              <a:t>Squad works   ·   8 min</a:t>
+              <a:t>Party works   ·   8 min</a:t>
             </a:r>
             <a:endParaRPr lang="en-US" sz="1500" dirty="0"/>
           </a:p>
@@ -7716,7 +7716,7 @@
                 <a:ea typeface="Arial" pitchFamily="34" charset="-122"/>
                 <a:cs typeface="Arial" pitchFamily="34" charset="-120"/>
               </a:rPr>
-              <a:t>Now switch: YOU play an AI agent. Take a role card; work SILENTLY on your own paper. Papers stay put. No questions — agents can't read minds.</a:t>
+              <a:t>Now switch: YOU play an AI agent. Take a role card; work SILENTLY on a blank sheet — not this worksheet. No questions: agents can't read minds.</a:t>
             </a:r>
             <a:endParaRPr lang="en-US" sz="1300" dirty="0"/>
           </a:p>
@@ -7858,7 +7858,7 @@
                 <a:ea typeface="Arial" pitchFamily="34" charset="-122"/>
                 <a:cs typeface="Arial" pitchFamily="34" charset="-120"/>
               </a:rPr>
-              <a:t>Everyone passes their OWN paper one seat left — you're the leader again. Run the CHECK rubric: SHIP IT or RUN IT BACK per check, then the note.</a:t>
+              <a:t>Pass that blank sheet one seat left; keep this worksheet — you're the leader again. CHECK rubric: SHIP IT or RUN IT BACK per row, then the note.</a:t>
             </a:r>
             <a:endParaRPr lang="en-US" sz="1300" dirty="0"/>
           </a:p>

</xml_diff>